<commit_message>
maj presentation + tests unitaires
</commit_message>
<xml_diff>
--- a/Fillion_Bertrand_6_presentation_022026.pptx
+++ b/Fillion_Bertrand_6_presentation_022026.pptx
@@ -45,12 +45,12 @@
   <p:notesSz cx="6858000" cy="9144000"/>
   <p:embeddedFontLst>
     <p:embeddedFont>
-      <p:font typeface="Kumbh Sans"/>
+      <p:font typeface="Kumbh Sans" pitchFamily="2" charset="77"/>
       <p:regular r:id="rId35"/>
       <p:bold r:id="rId36"/>
     </p:embeddedFont>
     <p:embeddedFont>
-      <p:font typeface="Quantico" panose="02000000000000000000"/>
+      <p:font typeface="Quantico" panose="02000000000000000000" pitchFamily="2" charset="77"/>
       <p:regular r:id="rId37"/>
       <p:bold r:id="rId38"/>
       <p:italic r:id="rId39"/>
@@ -14970,7 +14970,15 @@
             </a:pPr>
             <a:r>
               <a:rPr lang="fr-FR" dirty="0"/>
-              <a:t>Expériences : entrainement et monitoring avec différents modèles</a:t>
+              <a:t>Expériences : entrainement et </a:t>
+            </a:r>
+            <a:r>
+              <a:rPr lang="fr-FR" dirty="0" err="1"/>
+              <a:t>tracking</a:t>
+            </a:r>
+            <a:r>
+              <a:rPr lang="fr-FR" dirty="0"/>
+              <a:t> avec différents modèles</a:t>
             </a:r>
           </a:p>
           <a:p>
@@ -21489,8 +21497,8 @@
         </p:nvSpPr>
         <p:spPr>
           <a:xfrm rot="-224">
-            <a:off x="720019" y="2938623"/>
-            <a:ext cx="1796413" cy="496397"/>
+            <a:off x="720026" y="2938623"/>
+            <a:ext cx="1796413" cy="722934"/>
           </a:xfrm>
         </p:spPr>
         <p:txBody>
@@ -21503,6 +21511,15 @@
             <a:r>
               <a:rPr lang="fr-FR" sz="1100" dirty="0"/>
               <a:t>Développement local</a:t>
+            </a:r>
+          </a:p>
+          <a:p>
+            <a:pPr marL="139700" indent="0">
+              <a:buNone/>
+            </a:pPr>
+            <a:r>
+              <a:rPr lang="fr-FR" sz="1100" dirty="0"/>
+              <a:t>Modélisation + Api</a:t>
             </a:r>
           </a:p>
           <a:p>
@@ -23826,7 +23843,7 @@
         </p:nvSpPr>
         <p:spPr>
           <a:xfrm>
-            <a:off x="1725707" y="4326955"/>
+            <a:off x="1717543" y="4514733"/>
             <a:ext cx="1842881" cy="180309"/>
           </a:xfrm>
           <a:prstGeom prst="rect">

</xml_diff>

<commit_message>
modif notebook test api features_store
</commit_message>
<xml_diff>
--- a/Fillion_Bertrand_6_presentation_022026.pptx
+++ b/Fillion_Bertrand_6_presentation_022026.pptx
@@ -45,12 +45,12 @@
   <p:notesSz cx="6858000" cy="9144000"/>
   <p:embeddedFontLst>
     <p:embeddedFont>
-      <p:font typeface="Kumbh Sans" pitchFamily="2" charset="77"/>
+      <p:font typeface="Kumbh Sans"/>
       <p:regular r:id="rId35"/>
       <p:bold r:id="rId36"/>
     </p:embeddedFont>
     <p:embeddedFont>
-      <p:font typeface="Quantico" panose="02000000000000000000" pitchFamily="2" charset="77"/>
+      <p:font typeface="Quantico" panose="02000000000000000000"/>
       <p:regular r:id="rId37"/>
       <p:bold r:id="rId38"/>
       <p:italic r:id="rId39"/>
@@ -13357,8 +13357,8 @@
         </p:nvSpPr>
         <p:spPr>
           <a:xfrm rot="-224">
-            <a:off x="620215" y="1197136"/>
-            <a:ext cx="4203478" cy="1530302"/>
+            <a:off x="620225" y="1197136"/>
+            <a:ext cx="4203478" cy="1861078"/>
           </a:xfrm>
           <a:solidFill>
             <a:schemeClr val="bg2">
@@ -13450,6 +13450,17 @@
               <a:t>features</a:t>
             </a:r>
             <a:endParaRPr lang="fr-FR" sz="1200" dirty="0"/>
+          </a:p>
+          <a:p>
+            <a:pPr>
+              <a:lnSpc>
+                <a:spcPct val="150000"/>
+              </a:lnSpc>
+            </a:pPr>
+            <a:r>
+              <a:rPr lang="fr-FR" sz="1200" dirty="0"/>
+              <a:t>Export de données pour tests</a:t>
+            </a:r>
           </a:p>
         </p:txBody>
       </p:sp>
@@ -23123,6 +23134,36 @@
           <a:chExt cx="0" cy="0"/>
         </a:xfrm>
       </p:grpSpPr>
+      <p:pic>
+        <p:nvPicPr>
+          <p:cNvPr id="8" name="Image 7">
+            <a:extLst>
+              <a:ext uri="{FF2B5EF4-FFF2-40B4-BE49-F238E27FC236}">
+                <a16:creationId xmlns:a16="http://schemas.microsoft.com/office/drawing/2014/main" id="{C1D5A254-1969-BAD9-C35D-1B6C604AC459}"/>
+              </a:ext>
+            </a:extLst>
+          </p:cNvPr>
+          <p:cNvPicPr>
+            <a:picLocks noChangeAspect="1"/>
+          </p:cNvPicPr>
+          <p:nvPr/>
+        </p:nvPicPr>
+        <p:blipFill>
+          <a:blip r:embed="rId2"/>
+          <a:stretch>
+            <a:fillRect/>
+          </a:stretch>
+        </p:blipFill>
+        <p:spPr>
+          <a:xfrm>
+            <a:off x="2878720" y="1601245"/>
+            <a:ext cx="3648460" cy="3410861"/>
+          </a:xfrm>
+          <a:prstGeom prst="rect">
+            <a:avLst/>
+          </a:prstGeom>
+        </p:spPr>
+      </p:pic>
       <p:sp>
         <p:nvSpPr>
           <p:cNvPr id="2" name="Titre 1">
@@ -23227,109 +23268,58 @@
           </a:p>
         </p:txBody>
       </p:sp>
-      <p:grpSp>
-        <p:nvGrpSpPr>
-          <p:cNvPr id="7" name="Groupe 6">
+      <p:sp>
+        <p:nvSpPr>
+          <p:cNvPr id="6" name="Rectangle 5">
             <a:extLst>
               <a:ext uri="{FF2B5EF4-FFF2-40B4-BE49-F238E27FC236}">
-                <a16:creationId xmlns:a16="http://schemas.microsoft.com/office/drawing/2014/main" id="{54BAF66E-E72B-2D1D-7ECE-3B8BF3335BB3}"/>
+                <a16:creationId xmlns:a16="http://schemas.microsoft.com/office/drawing/2014/main" id="{384307AC-CA27-7DA1-245D-4AC58144D54B}"/>
               </a:ext>
             </a:extLst>
           </p:cNvPr>
-          <p:cNvGrpSpPr/>
+          <p:cNvSpPr/>
           <p:nvPr/>
-        </p:nvGrpSpPr>
-        <p:grpSpPr>
+        </p:nvSpPr>
+        <p:spPr>
           <a:xfrm>
-            <a:off x="2898288" y="1724026"/>
-            <a:ext cx="3491278" cy="2343607"/>
-            <a:chOff x="4714062" y="960847"/>
-            <a:chExt cx="3491278" cy="2343607"/>
+            <a:off x="3195369" y="4129090"/>
+            <a:ext cx="1294856" cy="190150"/>
           </a:xfrm>
-        </p:grpSpPr>
-        <p:pic>
-          <p:nvPicPr>
-            <p:cNvPr id="5" name="Image 4">
-              <a:extLst>
-                <a:ext uri="{FF2B5EF4-FFF2-40B4-BE49-F238E27FC236}">
-                  <a16:creationId xmlns:a16="http://schemas.microsoft.com/office/drawing/2014/main" id="{42987B99-283B-1321-981C-D346B3749882}"/>
-                </a:ext>
-              </a:extLst>
-            </p:cNvPr>
-            <p:cNvPicPr>
-              <a:picLocks noChangeAspect="1"/>
-            </p:cNvPicPr>
-            <p:nvPr/>
-          </p:nvPicPr>
-          <p:blipFill>
-            <a:blip r:embed="rId2"/>
-            <a:stretch>
-              <a:fillRect/>
-            </a:stretch>
-          </p:blipFill>
-          <p:spPr>
-            <a:xfrm>
-              <a:off x="4714062" y="960847"/>
-              <a:ext cx="3491278" cy="2343607"/>
-            </a:xfrm>
-            <a:prstGeom prst="rect">
-              <a:avLst/>
-            </a:prstGeom>
-          </p:spPr>
-        </p:pic>
-        <p:sp>
-          <p:nvSpPr>
-            <p:cNvPr id="6" name="Rectangle 5">
-              <a:extLst>
-                <a:ext uri="{FF2B5EF4-FFF2-40B4-BE49-F238E27FC236}">
-                  <a16:creationId xmlns:a16="http://schemas.microsoft.com/office/drawing/2014/main" id="{384307AC-CA27-7DA1-245D-4AC58144D54B}"/>
-                </a:ext>
-              </a:extLst>
-            </p:cNvPr>
-            <p:cNvSpPr/>
-            <p:nvPr/>
-          </p:nvSpPr>
-          <p:spPr>
-            <a:xfrm>
-              <a:off x="4944235" y="3113149"/>
-              <a:ext cx="1294725" cy="191305"/>
-            </a:xfrm>
-            <a:prstGeom prst="rect">
-              <a:avLst/>
-            </a:prstGeom>
-            <a:noFill/>
-            <a:ln>
-              <a:solidFill>
-                <a:srgbClr val="92D050"/>
-              </a:solidFill>
-            </a:ln>
-          </p:spPr>
-          <p:style>
-            <a:lnRef idx="2">
-              <a:schemeClr val="accent1">
-                <a:shade val="15000"/>
-              </a:schemeClr>
-            </a:lnRef>
-            <a:fillRef idx="1">
-              <a:schemeClr val="accent1"/>
-            </a:fillRef>
-            <a:effectRef idx="0">
-              <a:schemeClr val="accent1"/>
-            </a:effectRef>
-            <a:fontRef idx="minor">
-              <a:schemeClr val="lt1"/>
-            </a:fontRef>
-          </p:style>
-          <p:txBody>
-            <a:bodyPr rtlCol="0" anchor="ctr"/>
-            <a:lstStyle/>
-            <a:p>
-              <a:pPr algn="ctr"/>
-              <a:endParaRPr lang="fr-FR"/>
-            </a:p>
-          </p:txBody>
-        </p:sp>
-      </p:grpSp>
+          <a:prstGeom prst="rect">
+            <a:avLst/>
+          </a:prstGeom>
+          <a:noFill/>
+          <a:ln>
+            <a:solidFill>
+              <a:srgbClr val="92D050"/>
+            </a:solidFill>
+          </a:ln>
+        </p:spPr>
+        <p:style>
+          <a:lnRef idx="2">
+            <a:schemeClr val="accent1">
+              <a:shade val="15000"/>
+            </a:schemeClr>
+          </a:lnRef>
+          <a:fillRef idx="1">
+            <a:schemeClr val="accent1"/>
+          </a:fillRef>
+          <a:effectRef idx="0">
+            <a:schemeClr val="accent1"/>
+          </a:effectRef>
+          <a:fontRef idx="minor">
+            <a:schemeClr val="lt1"/>
+          </a:fontRef>
+        </p:style>
+        <p:txBody>
+          <a:bodyPr rtlCol="0" anchor="ctr"/>
+          <a:lstStyle/>
+          <a:p>
+            <a:pPr algn="ctr"/>
+            <a:endParaRPr lang="fr-FR"/>
+          </a:p>
+        </p:txBody>
+      </p:sp>
     </p:spTree>
     <p:extLst>
       <p:ext uri="{BB962C8B-B14F-4D97-AF65-F5344CB8AC3E}">
@@ -23911,6 +23901,36 @@
           <a:chExt cx="0" cy="0"/>
         </a:xfrm>
       </p:grpSpPr>
+      <p:pic>
+        <p:nvPicPr>
+          <p:cNvPr id="13" name="Image 12">
+            <a:extLst>
+              <a:ext uri="{FF2B5EF4-FFF2-40B4-BE49-F238E27FC236}">
+                <a16:creationId xmlns:a16="http://schemas.microsoft.com/office/drawing/2014/main" id="{F902A066-171D-E590-B005-C4272830C463}"/>
+              </a:ext>
+            </a:extLst>
+          </p:cNvPr>
+          <p:cNvPicPr>
+            <a:picLocks noChangeAspect="1"/>
+          </p:cNvPicPr>
+          <p:nvPr/>
+        </p:nvPicPr>
+        <p:blipFill>
+          <a:blip r:embed="rId2"/>
+          <a:stretch>
+            <a:fillRect/>
+          </a:stretch>
+        </p:blipFill>
+        <p:spPr>
+          <a:xfrm>
+            <a:off x="3810613" y="1486766"/>
+            <a:ext cx="4894772" cy="3420615"/>
+          </a:xfrm>
+          <a:prstGeom prst="rect">
+            <a:avLst/>
+          </a:prstGeom>
+        </p:spPr>
+      </p:pic>
       <p:sp>
         <p:nvSpPr>
           <p:cNvPr id="2" name="Titre 1">
@@ -23957,8 +23977,8 @@
         </p:nvSpPr>
         <p:spPr>
           <a:xfrm rot="-224">
-            <a:off x="720012" y="821932"/>
-            <a:ext cx="5510854" cy="447057"/>
+            <a:off x="720012" y="821847"/>
+            <a:ext cx="8154570" cy="447057"/>
           </a:xfrm>
           <a:solidFill>
             <a:schemeClr val="bg2">
@@ -23977,7 +23997,19 @@
             </a:r>
             <a:r>
               <a:rPr lang="fr-FR" i="1" dirty="0" err="1"/>
-              <a:t>application_test.csv</a:t>
+              <a:t>features_store.parquet</a:t>
+            </a:r>
+            <a:r>
+              <a:rPr lang="fr-FR" dirty="0"/>
+              <a:t> (données issues du </a:t>
+            </a:r>
+            <a:r>
+              <a:rPr lang="fr-FR" dirty="0" err="1"/>
+              <a:t>feature</a:t>
+            </a:r>
+            <a:r>
+              <a:rPr lang="fr-FR" dirty="0"/>
+              <a:t> engineering)</a:t>
             </a:r>
             <a:endParaRPr lang="fr-FR" i="1" dirty="0"/>
           </a:p>
@@ -24012,161 +24044,447 @@
           </a:p>
         </p:txBody>
       </p:sp>
-      <p:grpSp>
-        <p:nvGrpSpPr>
-          <p:cNvPr id="8" name="Groupe 7">
+      <p:sp>
+        <p:nvSpPr>
+          <p:cNvPr id="6" name="Rectangle 5">
             <a:extLst>
               <a:ext uri="{FF2B5EF4-FFF2-40B4-BE49-F238E27FC236}">
-                <a16:creationId xmlns:a16="http://schemas.microsoft.com/office/drawing/2014/main" id="{590E8A7A-EE83-138F-E75C-F73A27239403}"/>
+                <a16:creationId xmlns:a16="http://schemas.microsoft.com/office/drawing/2014/main" id="{A49E20FB-597C-0275-0B83-6366B3E7AD08}"/>
               </a:ext>
             </a:extLst>
           </p:cNvPr>
-          <p:cNvGrpSpPr/>
+          <p:cNvSpPr/>
           <p:nvPr/>
-        </p:nvGrpSpPr>
-        <p:grpSpPr>
+        </p:nvSpPr>
+        <p:spPr>
           <a:xfrm>
-            <a:off x="2086733" y="1552099"/>
-            <a:ext cx="4970533" cy="3117969"/>
-            <a:chOff x="1818732" y="1552099"/>
-            <a:chExt cx="4970533" cy="3117969"/>
+            <a:off x="4259765" y="2320301"/>
+            <a:ext cx="2627127" cy="311388"/>
           </a:xfrm>
-        </p:grpSpPr>
-        <p:pic>
-          <p:nvPicPr>
-            <p:cNvPr id="5" name="Image 4">
-              <a:extLst>
-                <a:ext uri="{FF2B5EF4-FFF2-40B4-BE49-F238E27FC236}">
-                  <a16:creationId xmlns:a16="http://schemas.microsoft.com/office/drawing/2014/main" id="{4D4E468F-E7EA-FA81-BB02-38C796032E70}"/>
-                </a:ext>
-              </a:extLst>
-            </p:cNvPr>
-            <p:cNvPicPr>
-              <a:picLocks noChangeAspect="1"/>
-            </p:cNvPicPr>
-            <p:nvPr/>
-          </p:nvPicPr>
-          <p:blipFill>
-            <a:blip r:embed="rId2"/>
-            <a:stretch>
-              <a:fillRect/>
-            </a:stretch>
-          </p:blipFill>
-          <p:spPr>
-            <a:xfrm>
-              <a:off x="1818732" y="1552099"/>
-              <a:ext cx="4970533" cy="3093693"/>
-            </a:xfrm>
-            <a:prstGeom prst="rect">
-              <a:avLst/>
-            </a:prstGeom>
-          </p:spPr>
-        </p:pic>
-        <p:sp>
-          <p:nvSpPr>
-            <p:cNvPr id="6" name="Rectangle 5">
-              <a:extLst>
-                <a:ext uri="{FF2B5EF4-FFF2-40B4-BE49-F238E27FC236}">
-                  <a16:creationId xmlns:a16="http://schemas.microsoft.com/office/drawing/2014/main" id="{A49E20FB-597C-0275-0B83-6366B3E7AD08}"/>
-                </a:ext>
-              </a:extLst>
-            </p:cNvPr>
-            <p:cNvSpPr/>
-            <p:nvPr/>
-          </p:nvSpPr>
-          <p:spPr>
-            <a:xfrm>
-              <a:off x="2242152" y="2427681"/>
-              <a:ext cx="2524714" cy="419399"/>
-            </a:xfrm>
-            <a:prstGeom prst="rect">
-              <a:avLst/>
-            </a:prstGeom>
+          <a:prstGeom prst="rect">
+            <a:avLst/>
+          </a:prstGeom>
+          <a:noFill/>
+          <a:ln>
+            <a:solidFill>
+              <a:srgbClr val="92D050"/>
+            </a:solidFill>
+          </a:ln>
+        </p:spPr>
+        <p:style>
+          <a:lnRef idx="2">
+            <a:schemeClr val="accent1">
+              <a:shade val="15000"/>
+            </a:schemeClr>
+          </a:lnRef>
+          <a:fillRef idx="1">
+            <a:schemeClr val="accent1"/>
+          </a:fillRef>
+          <a:effectRef idx="0">
+            <a:schemeClr val="accent1"/>
+          </a:effectRef>
+          <a:fontRef idx="minor">
+            <a:schemeClr val="lt1"/>
+          </a:fontRef>
+        </p:style>
+        <p:txBody>
+          <a:bodyPr rtlCol="0" anchor="ctr"/>
+          <a:lstStyle/>
+          <a:p>
+            <a:pPr algn="ctr"/>
+            <a:endParaRPr lang="fr-FR"/>
+          </a:p>
+        </p:txBody>
+      </p:sp>
+      <p:sp>
+        <p:nvSpPr>
+          <p:cNvPr id="7" name="Rectangle 6">
+            <a:extLst>
+              <a:ext uri="{FF2B5EF4-FFF2-40B4-BE49-F238E27FC236}">
+                <a16:creationId xmlns:a16="http://schemas.microsoft.com/office/drawing/2014/main" id="{B09A5B65-4DA4-7DC9-5651-BC930E1AF66D}"/>
+              </a:ext>
+            </a:extLst>
+          </p:cNvPr>
+          <p:cNvSpPr/>
+          <p:nvPr/>
+        </p:nvSpPr>
+        <p:spPr>
+          <a:xfrm>
+            <a:off x="3924998" y="4321920"/>
+            <a:ext cx="4720914" cy="585462"/>
+          </a:xfrm>
+          <a:prstGeom prst="rect">
+            <a:avLst/>
+          </a:prstGeom>
+          <a:noFill/>
+          <a:ln>
+            <a:solidFill>
+              <a:srgbClr val="92D050"/>
+            </a:solidFill>
+          </a:ln>
+        </p:spPr>
+        <p:style>
+          <a:lnRef idx="2">
+            <a:schemeClr val="accent1">
+              <a:shade val="15000"/>
+            </a:schemeClr>
+          </a:lnRef>
+          <a:fillRef idx="1">
+            <a:schemeClr val="accent1"/>
+          </a:fillRef>
+          <a:effectRef idx="0">
+            <a:schemeClr val="accent1"/>
+          </a:effectRef>
+          <a:fontRef idx="minor">
+            <a:schemeClr val="lt1"/>
+          </a:fontRef>
+        </p:style>
+        <p:txBody>
+          <a:bodyPr rtlCol="0" anchor="ctr"/>
+          <a:lstStyle/>
+          <a:p>
+            <a:pPr algn="ctr"/>
+            <a:endParaRPr lang="fr-FR"/>
+          </a:p>
+        </p:txBody>
+      </p:sp>
+      <p:sp>
+        <p:nvSpPr>
+          <p:cNvPr id="12" name="Sous-titre 2">
+            <a:extLst>
+              <a:ext uri="{FF2B5EF4-FFF2-40B4-BE49-F238E27FC236}">
+                <a16:creationId xmlns:a16="http://schemas.microsoft.com/office/drawing/2014/main" id="{0474268A-E854-E7B7-0BCE-8B40A42D439A}"/>
+              </a:ext>
+            </a:extLst>
+          </p:cNvPr>
+          <p:cNvSpPr txBox="1">
+            <a:spLocks/>
+          </p:cNvSpPr>
+          <p:nvPr/>
+        </p:nvSpPr>
+        <p:spPr>
+          <a:xfrm rot="-224">
+            <a:off x="716474" y="1486859"/>
+            <a:ext cx="2857658" cy="2631657"/>
+          </a:xfrm>
+          <a:prstGeom prst="rect">
+            <a:avLst/>
+          </a:prstGeom>
+          <a:solidFill>
+            <a:schemeClr val="bg2">
+              <a:lumMod val="90000"/>
+              <a:lumOff val="10000"/>
+            </a:schemeClr>
+          </a:solidFill>
+          <a:ln>
             <a:noFill/>
-            <a:ln>
-              <a:solidFill>
-                <a:srgbClr val="92D050"/>
-              </a:solidFill>
-            </a:ln>
-          </p:spPr>
-          <p:style>
-            <a:lnRef idx="2">
-              <a:schemeClr val="accent1">
-                <a:shade val="15000"/>
-              </a:schemeClr>
-            </a:lnRef>
-            <a:fillRef idx="1">
-              <a:schemeClr val="accent1"/>
-            </a:fillRef>
-            <a:effectRef idx="0">
-              <a:schemeClr val="accent1"/>
-            </a:effectRef>
-            <a:fontRef idx="minor">
-              <a:schemeClr val="lt1"/>
-            </a:fontRef>
-          </p:style>
-          <p:txBody>
-            <a:bodyPr rtlCol="0" anchor="ctr"/>
-            <a:lstStyle/>
-            <a:p>
-              <a:pPr algn="ctr"/>
-              <a:endParaRPr lang="fr-FR"/>
-            </a:p>
-          </p:txBody>
-        </p:sp>
-        <p:sp>
-          <p:nvSpPr>
-            <p:cNvPr id="7" name="Rectangle 6">
-              <a:extLst>
-                <a:ext uri="{FF2B5EF4-FFF2-40B4-BE49-F238E27FC236}">
-                  <a16:creationId xmlns:a16="http://schemas.microsoft.com/office/drawing/2014/main" id="{B09A5B65-4DA4-7DC9-5651-BC930E1AF66D}"/>
-                </a:ext>
-              </a:extLst>
-            </p:cNvPr>
-            <p:cNvSpPr/>
-            <p:nvPr/>
-          </p:nvSpPr>
-          <p:spPr>
-            <a:xfrm>
-              <a:off x="1941398" y="4250669"/>
-              <a:ext cx="4314402" cy="419399"/>
-            </a:xfrm>
-            <a:prstGeom prst="rect">
-              <a:avLst/>
-            </a:prstGeom>
-            <a:noFill/>
-            <a:ln>
-              <a:solidFill>
-                <a:srgbClr val="92D050"/>
-              </a:solidFill>
-            </a:ln>
-          </p:spPr>
-          <p:style>
-            <a:lnRef idx="2">
-              <a:schemeClr val="accent1">
-                <a:shade val="15000"/>
-              </a:schemeClr>
-            </a:lnRef>
-            <a:fillRef idx="1">
-              <a:schemeClr val="accent1"/>
-            </a:fillRef>
-            <a:effectRef idx="0">
-              <a:schemeClr val="accent1"/>
-            </a:effectRef>
-            <a:fontRef idx="minor">
-              <a:schemeClr val="lt1"/>
-            </a:fontRef>
-          </p:style>
-          <p:txBody>
-            <a:bodyPr rtlCol="0" anchor="ctr"/>
-            <a:lstStyle/>
-            <a:p>
-              <a:pPr algn="ctr"/>
-              <a:endParaRPr lang="fr-FR"/>
-            </a:p>
-          </p:txBody>
-        </p:sp>
-      </p:grpSp>
+          </a:ln>
+        </p:spPr>
+        <p:txBody>
+          <a:bodyPr spcFirstLastPara="1" wrap="square" lIns="91425" tIns="91425" rIns="91425" bIns="91425" anchor="t" anchorCtr="0">
+            <a:noAutofit/>
+          </a:bodyPr>
+          <a:lstStyle>
+            <a:defPPr marR="0" lvl="0" algn="l" rtl="0">
+              <a:lnSpc>
+                <a:spcPct val="100000"/>
+              </a:lnSpc>
+              <a:spcBef>
+                <a:spcPts val="0"/>
+              </a:spcBef>
+              <a:spcAft>
+                <a:spcPts val="0"/>
+              </a:spcAft>
+            </a:defPPr>
+            <a:lvl1pPr marL="457200" marR="0" lvl="0" indent="-317500" algn="l" rtl="0">
+              <a:lnSpc>
+                <a:spcPct val="100000"/>
+              </a:lnSpc>
+              <a:spcBef>
+                <a:spcPts val="0"/>
+              </a:spcBef>
+              <a:spcAft>
+                <a:spcPts val="0"/>
+              </a:spcAft>
+              <a:buClr>
+                <a:schemeClr val="lt1"/>
+              </a:buClr>
+              <a:buSzPts val="1400"/>
+              <a:buFont typeface="Kumbh Sans"/>
+              <a:buChar char="●"/>
+              <a:defRPr sz="1400" b="0" i="0" u="none" strike="noStrike" cap="none">
+                <a:solidFill>
+                  <a:schemeClr val="dk1"/>
+                </a:solidFill>
+                <a:latin typeface="Kumbh Sans"/>
+                <a:ea typeface="Kumbh Sans"/>
+                <a:cs typeface="Kumbh Sans"/>
+                <a:sym typeface="Kumbh Sans"/>
+              </a:defRPr>
+            </a:lvl1pPr>
+            <a:lvl2pPr marL="914400" marR="0" lvl="1" indent="-317500" algn="ctr" rtl="0">
+              <a:lnSpc>
+                <a:spcPct val="100000"/>
+              </a:lnSpc>
+              <a:spcBef>
+                <a:spcPts val="0"/>
+              </a:spcBef>
+              <a:spcAft>
+                <a:spcPts val="0"/>
+              </a:spcAft>
+              <a:buClr>
+                <a:schemeClr val="dk1"/>
+              </a:buClr>
+              <a:buSzPts val="1400"/>
+              <a:buFont typeface="Kumbh Sans"/>
+              <a:buChar char="○"/>
+              <a:defRPr sz="1400" b="0" i="0" u="none" strike="noStrike" cap="none">
+                <a:solidFill>
+                  <a:schemeClr val="dk1"/>
+                </a:solidFill>
+                <a:latin typeface="Kumbh Sans"/>
+                <a:ea typeface="Kumbh Sans"/>
+                <a:cs typeface="Kumbh Sans"/>
+                <a:sym typeface="Kumbh Sans"/>
+              </a:defRPr>
+            </a:lvl2pPr>
+            <a:lvl3pPr marL="1371600" marR="0" lvl="2" indent="-317500" algn="ctr" rtl="0">
+              <a:lnSpc>
+                <a:spcPct val="100000"/>
+              </a:lnSpc>
+              <a:spcBef>
+                <a:spcPts val="1600"/>
+              </a:spcBef>
+              <a:spcAft>
+                <a:spcPts val="0"/>
+              </a:spcAft>
+              <a:buClr>
+                <a:schemeClr val="dk1"/>
+              </a:buClr>
+              <a:buSzPts val="1400"/>
+              <a:buFont typeface="Kumbh Sans"/>
+              <a:buChar char="■"/>
+              <a:defRPr sz="1400" b="0" i="0" u="none" strike="noStrike" cap="none">
+                <a:solidFill>
+                  <a:schemeClr val="dk1"/>
+                </a:solidFill>
+                <a:latin typeface="Kumbh Sans"/>
+                <a:ea typeface="Kumbh Sans"/>
+                <a:cs typeface="Kumbh Sans"/>
+                <a:sym typeface="Kumbh Sans"/>
+              </a:defRPr>
+            </a:lvl3pPr>
+            <a:lvl4pPr marL="1828800" marR="0" lvl="3" indent="-317500" algn="ctr" rtl="0">
+              <a:lnSpc>
+                <a:spcPct val="100000"/>
+              </a:lnSpc>
+              <a:spcBef>
+                <a:spcPts val="1600"/>
+              </a:spcBef>
+              <a:spcAft>
+                <a:spcPts val="0"/>
+              </a:spcAft>
+              <a:buClr>
+                <a:schemeClr val="dk1"/>
+              </a:buClr>
+              <a:buSzPts val="1400"/>
+              <a:buFont typeface="Kumbh Sans"/>
+              <a:buChar char="●"/>
+              <a:defRPr sz="1400" b="0" i="0" u="none" strike="noStrike" cap="none">
+                <a:solidFill>
+                  <a:schemeClr val="dk1"/>
+                </a:solidFill>
+                <a:latin typeface="Kumbh Sans"/>
+                <a:ea typeface="Kumbh Sans"/>
+                <a:cs typeface="Kumbh Sans"/>
+                <a:sym typeface="Kumbh Sans"/>
+              </a:defRPr>
+            </a:lvl4pPr>
+            <a:lvl5pPr marL="2286000" marR="0" lvl="4" indent="-317500" algn="ctr" rtl="0">
+              <a:lnSpc>
+                <a:spcPct val="100000"/>
+              </a:lnSpc>
+              <a:spcBef>
+                <a:spcPts val="1600"/>
+              </a:spcBef>
+              <a:spcAft>
+                <a:spcPts val="0"/>
+              </a:spcAft>
+              <a:buClr>
+                <a:schemeClr val="dk1"/>
+              </a:buClr>
+              <a:buSzPts val="1400"/>
+              <a:buFont typeface="Kumbh Sans"/>
+              <a:buChar char="○"/>
+              <a:defRPr sz="1400" b="0" i="0" u="none" strike="noStrike" cap="none">
+                <a:solidFill>
+                  <a:schemeClr val="dk1"/>
+                </a:solidFill>
+                <a:latin typeface="Kumbh Sans"/>
+                <a:ea typeface="Kumbh Sans"/>
+                <a:cs typeface="Kumbh Sans"/>
+                <a:sym typeface="Kumbh Sans"/>
+              </a:defRPr>
+            </a:lvl5pPr>
+            <a:lvl6pPr marL="2743200" marR="0" lvl="5" indent="-317500" algn="ctr" rtl="0">
+              <a:lnSpc>
+                <a:spcPct val="100000"/>
+              </a:lnSpc>
+              <a:spcBef>
+                <a:spcPts val="1600"/>
+              </a:spcBef>
+              <a:spcAft>
+                <a:spcPts val="0"/>
+              </a:spcAft>
+              <a:buClr>
+                <a:schemeClr val="dk1"/>
+              </a:buClr>
+              <a:buSzPts val="1400"/>
+              <a:buFont typeface="Kumbh Sans"/>
+              <a:buChar char="■"/>
+              <a:defRPr sz="1400" b="0" i="0" u="none" strike="noStrike" cap="none">
+                <a:solidFill>
+                  <a:schemeClr val="dk1"/>
+                </a:solidFill>
+                <a:latin typeface="Kumbh Sans"/>
+                <a:ea typeface="Kumbh Sans"/>
+                <a:cs typeface="Kumbh Sans"/>
+                <a:sym typeface="Kumbh Sans"/>
+              </a:defRPr>
+            </a:lvl6pPr>
+            <a:lvl7pPr marL="3200400" marR="0" lvl="6" indent="-317500" algn="ctr" rtl="0">
+              <a:lnSpc>
+                <a:spcPct val="100000"/>
+              </a:lnSpc>
+              <a:spcBef>
+                <a:spcPts val="1600"/>
+              </a:spcBef>
+              <a:spcAft>
+                <a:spcPts val="0"/>
+              </a:spcAft>
+              <a:buClr>
+                <a:schemeClr val="dk1"/>
+              </a:buClr>
+              <a:buSzPts val="1400"/>
+              <a:buFont typeface="Kumbh Sans"/>
+              <a:buChar char="●"/>
+              <a:defRPr sz="1400" b="0" i="0" u="none" strike="noStrike" cap="none">
+                <a:solidFill>
+                  <a:schemeClr val="dk1"/>
+                </a:solidFill>
+                <a:latin typeface="Kumbh Sans"/>
+                <a:ea typeface="Kumbh Sans"/>
+                <a:cs typeface="Kumbh Sans"/>
+                <a:sym typeface="Kumbh Sans"/>
+              </a:defRPr>
+            </a:lvl7pPr>
+            <a:lvl8pPr marL="3657600" marR="0" lvl="7" indent="-317500" algn="ctr" rtl="0">
+              <a:lnSpc>
+                <a:spcPct val="100000"/>
+              </a:lnSpc>
+              <a:spcBef>
+                <a:spcPts val="1600"/>
+              </a:spcBef>
+              <a:spcAft>
+                <a:spcPts val="0"/>
+              </a:spcAft>
+              <a:buClr>
+                <a:schemeClr val="dk1"/>
+              </a:buClr>
+              <a:buSzPts val="1400"/>
+              <a:buFont typeface="Kumbh Sans"/>
+              <a:buChar char="○"/>
+              <a:defRPr sz="1400" b="0" i="0" u="none" strike="noStrike" cap="none">
+                <a:solidFill>
+                  <a:schemeClr val="dk1"/>
+                </a:solidFill>
+                <a:latin typeface="Kumbh Sans"/>
+                <a:ea typeface="Kumbh Sans"/>
+                <a:cs typeface="Kumbh Sans"/>
+                <a:sym typeface="Kumbh Sans"/>
+              </a:defRPr>
+            </a:lvl8pPr>
+            <a:lvl9pPr marL="4114800" marR="0" lvl="8" indent="-317500" algn="ctr" rtl="0">
+              <a:lnSpc>
+                <a:spcPct val="100000"/>
+              </a:lnSpc>
+              <a:spcBef>
+                <a:spcPts val="1600"/>
+              </a:spcBef>
+              <a:spcAft>
+                <a:spcPts val="1600"/>
+              </a:spcAft>
+              <a:buClr>
+                <a:schemeClr val="dk1"/>
+              </a:buClr>
+              <a:buSzPts val="1400"/>
+              <a:buFont typeface="Kumbh Sans"/>
+              <a:buChar char="■"/>
+              <a:defRPr sz="1400" b="0" i="0" u="none" strike="noStrike" cap="none">
+                <a:solidFill>
+                  <a:schemeClr val="dk1"/>
+                </a:solidFill>
+                <a:latin typeface="Kumbh Sans"/>
+                <a:ea typeface="Kumbh Sans"/>
+                <a:cs typeface="Kumbh Sans"/>
+                <a:sym typeface="Kumbh Sans"/>
+              </a:defRPr>
+            </a:lvl9pPr>
+          </a:lstStyle>
+          <a:p>
+            <a:pPr>
+              <a:lnSpc>
+                <a:spcPct val="150000"/>
+              </a:lnSpc>
+            </a:pPr>
+            <a:r>
+              <a:rPr lang="fr-FR" sz="1000" dirty="0"/>
+              <a:t>Scénario de test :</a:t>
+            </a:r>
+          </a:p>
+          <a:p>
+            <a:pPr lvl="1" algn="l">
+              <a:lnSpc>
+                <a:spcPct val="150000"/>
+              </a:lnSpc>
+            </a:pPr>
+            <a:r>
+              <a:rPr lang="fr-FR" sz="1000" dirty="0"/>
+              <a:t>On récupère un identifiant client (SK_ID_CURR) que le modèle n’a jamais vu.</a:t>
+            </a:r>
+          </a:p>
+          <a:p>
+            <a:pPr lvl="1" algn="l">
+              <a:lnSpc>
+                <a:spcPct val="150000"/>
+              </a:lnSpc>
+            </a:pPr>
+            <a:r>
+              <a:rPr lang="fr-FR" sz="1000" dirty="0"/>
+              <a:t>On considère que les données du client ont été renseignées et agrégées.</a:t>
+            </a:r>
+          </a:p>
+          <a:p>
+            <a:pPr lvl="1" algn="l">
+              <a:lnSpc>
+                <a:spcPct val="150000"/>
+              </a:lnSpc>
+            </a:pPr>
+            <a:r>
+              <a:rPr lang="fr-FR" sz="1000" dirty="0"/>
+              <a:t>L’api récupère les données du client et effectue une prédiction.</a:t>
+            </a:r>
+          </a:p>
+          <a:p>
+            <a:pPr lvl="1" algn="l">
+              <a:lnSpc>
+                <a:spcPct val="150000"/>
+              </a:lnSpc>
+            </a:pPr>
+            <a:endParaRPr lang="fr-FR" sz="1000" dirty="0"/>
+          </a:p>
+        </p:txBody>
+      </p:sp>
     </p:spTree>
     <p:extLst>
       <p:ext uri="{BB962C8B-B14F-4D97-AF65-F5344CB8AC3E}">
@@ -24413,8 +24731,8 @@
         </p:nvSpPr>
         <p:spPr>
           <a:xfrm rot="-224">
-            <a:off x="716535" y="1341181"/>
-            <a:ext cx="7824218" cy="2242080"/>
+            <a:off x="716551" y="1341181"/>
+            <a:ext cx="7824218" cy="2725300"/>
           </a:xfrm>
           <a:solidFill>
             <a:schemeClr val="bg2">
@@ -24457,6 +24775,17 @@
             <a:r>
               <a:rPr lang="fr-FR" dirty="0"/>
               <a:t>Détermination d’un seuil métier</a:t>
+            </a:r>
+          </a:p>
+          <a:p>
+            <a:pPr>
+              <a:lnSpc>
+                <a:spcPct val="150000"/>
+              </a:lnSpc>
+            </a:pPr>
+            <a:r>
+              <a:rPr lang="fr-FR" dirty="0"/>
+              <a:t>L’api est fonctionnelle et déployée.</a:t>
             </a:r>
           </a:p>
           <a:p>

</xml_diff>